<commit_message>
Annotate UniNav VAE and geometry sources with terminology definitions
</commit_message>
<xml_diff>
--- a/presentations/uninav_io02_encoding_architecture_cn.pptx
+++ b/presentations/uninav_io02_encoding_architecture_cn.pptx
@@ -533,6 +533,11 @@
           <a:p>
             <a:r>
               <a:t>单步网络以噪声水平为条件，由不同输出头预测v_theta,vid/traj/cam，目标u_m=epsilon_m-x_m。三者更新量形状分别与对应视频latent、6×3轨迹和几何token目标匹配，不是图像像素、物理速度或最终去噪结果。采样迭代再得到干净表示；视频经冻结VAE解码RGB，轨迹直接作为连续数值，不需要VAE；几何保持特征形式，非必须直接提供机器人执行。</a:t>
+            </a:r>
+          </a:p>
+          <a:p>
+            <a:r>
+              <a:t>模块来源补充：Wang,A.等（2025），Wan: Open and Advanced Large-Scale Video Generative Models，arXiv:2503.20314，https://arxiv.org/abs/2503.20314。UniNav §3.2对视频VAE引用Wang等2025，§4.1明确Wan2.1-T2V-1.3B主干与冻结视频VAE。这里是Wan预训练视频VAE，不是UniNav新训练的编码器；并未独立核对Wan技术报告的具体压缩倍率，也不能直接代作UniNav设置。DA3来源Lin,H.等（2025），Depth Anything 3: Recovering the Visual Space from Any Views，arXiv:2511.10647，https://arxiv.org/abs/2511.10647。切块是将特征张量划分为局部时空块，嵌入将每块映射至共享隐藏维度D，D表示每token的数字个数；轨迹MLP把每航点3维映射到D维。论文未披露足够逐层尺寸，不补造。</a:t>
             </a:r>
           </a:p>
           <a:p>
@@ -4145,8 +4150,8 @@
         </p:nvSpPr>
         <p:spPr>
           <a:xfrm>
-            <a:off x="2889504" y="3172968"/>
-            <a:ext cx="3273552" cy="182880"/>
+            <a:off x="2889504" y="3154680"/>
+            <a:ext cx="3273552" cy="219456"/>
           </a:xfrm>
           <a:prstGeom prst="rect">
             <a:avLst/>
@@ -4172,7 +4177,7 @@
               </a:defRPr>
             </a:pPr>
             <a:r>
-              <a:t>得到历史、目标条件向量；不作为加噪目标</a:t>
+              <a:t>历史、目标是已知条件；VAE 编码后保持为条件向量</a:t>
             </a:r>
           </a:p>
         </p:txBody>
@@ -4471,8 +4476,8 @@
         </p:nvSpPr>
         <p:spPr>
           <a:xfrm>
-            <a:off x="2889504" y="3950208"/>
-            <a:ext cx="3273552" cy="182880"/>
+            <a:off x="2889504" y="3931920"/>
+            <a:ext cx="3273552" cy="219456"/>
           </a:xfrm>
           <a:prstGeom prst="rect">
             <a:avLst/>
@@ -4498,7 +4503,7 @@
               </a:defRPr>
             </a:pPr>
             <a:r>
-              <a:t>在压缩的视觉特征空间中加噪</a:t>
+              <a:t>切块=把特征分组；嵌入=把每块映射到共享维度 D</a:t>
             </a:r>
           </a:p>
         </p:txBody>
@@ -4797,8 +4802,8 @@
         </p:nvSpPr>
         <p:spPr>
           <a:xfrm>
-            <a:off x="2889504" y="4727448"/>
-            <a:ext cx="3273552" cy="182880"/>
+            <a:off x="2889504" y="4709159"/>
+            <a:ext cx="3273552" cy="219456"/>
           </a:xfrm>
           <a:prstGeom prst="rect">
             <a:avLst/>
@@ -4824,7 +4829,7 @@
               </a:defRPr>
             </a:pPr>
             <a:r>
-              <a:t>每个航点映射为 1 个向量，共 6 个</a:t>
+              <a:t>MLP=全连接映射；每航点 3 维→D 维，共 6 个</a:t>
             </a:r>
           </a:p>
         </p:txBody>
@@ -5123,8 +5128,8 @@
         </p:nvSpPr>
         <p:spPr>
           <a:xfrm>
-            <a:off x="2889504" y="5504688"/>
-            <a:ext cx="3273552" cy="182880"/>
+            <a:off x="2889504" y="5486400"/>
+            <a:ext cx="3273552" cy="219456"/>
           </a:xfrm>
           <a:prstGeom prst="rect">
             <a:avLst/>
@@ -5140,9 +5145,25 @@
           <a:p>
             <a:pPr>
               <a:spcAft>
-                <a:spcPts val="700"/>
+                <a:spcPts val="0"/>
               </a:spcAft>
-              <a:defRPr sz="800" b="0">
+              <a:defRPr sz="700" b="0">
+                <a:solidFill>
+                  <a:srgbClr val="62748A"/>
+                </a:solidFill>
+                <a:latin typeface="Noto Sans CJK SC"/>
+              </a:defRPr>
+            </a:pPr>
+            <a:r>
+              <a:t>DA3：Depth Anything 3（Lin 等，2025）</a:t>
+            </a:r>
+          </a:p>
+          <a:p>
+            <a:pPr>
+              <a:spcAft>
+                <a:spcPts val="0"/>
+              </a:spcAft>
+              <a:defRPr sz="700">
                 <a:solidFill>
                   <a:srgbClr val="62748A"/>
                 </a:solidFill>
@@ -5435,8 +5456,8 @@
         </p:nvSpPr>
         <p:spPr>
           <a:xfrm>
-            <a:off x="6729984" y="5349240"/>
-            <a:ext cx="1289304" cy="210312"/>
+            <a:off x="6729984" y="5157216"/>
+            <a:ext cx="1289304" cy="228600"/>
           </a:xfrm>
           <a:prstGeom prst="rect">
             <a:avLst/>
@@ -5454,7 +5475,47 @@
               <a:spcAft>
                 <a:spcPts val="700"/>
               </a:spcAft>
-              <a:defRPr sz="900" b="0">
+              <a:defRPr sz="800" b="0">
+                <a:solidFill>
+                  <a:srgbClr val="62748A"/>
+                </a:solidFill>
+                <a:latin typeface="Noto Sans CJK SC"/>
+              </a:defRPr>
+            </a:pPr>
+            <a:r>
+              <a:t>Wan2.1 初始化</a:t>
+            </a:r>
+          </a:p>
+        </p:txBody>
+      </p:sp>
+      <p:sp>
+        <p:nvSpPr>
+          <p:cNvPr id="48" name="TextBox 47"/>
+          <p:cNvSpPr txBox="1"/>
+          <p:nvPr/>
+        </p:nvSpPr>
+        <p:spPr>
+          <a:xfrm>
+            <a:off x="6729984" y="5486400"/>
+            <a:ext cx="1289304" cy="182880"/>
+          </a:xfrm>
+          <a:prstGeom prst="rect">
+            <a:avLst/>
+          </a:prstGeom>
+          <a:noFill/>
+          <a:effectLst/>
+        </p:spPr>
+        <p:txBody>
+          <a:bodyPr wrap="none" lIns="0" rIns="0" tIns="0" bIns="0">
+            <a:spAutoFit/>
+          </a:bodyPr>
+          <a:lstStyle/>
+          <a:p>
+            <a:pPr algn="ctr">
+              <a:spcAft>
+                <a:spcPts val="700"/>
+              </a:spcAft>
+              <a:defRPr sz="800" b="0">
                 <a:solidFill>
                   <a:srgbClr val="148D91"/>
                 </a:solidFill>
@@ -5469,14 +5530,575 @@
       </p:sp>
       <p:sp>
         <p:nvSpPr>
-          <p:cNvPr id="48" name="TextBox 47"/>
+          <p:cNvPr id="49" name="TextBox 48"/>
           <p:cNvSpPr txBox="1"/>
           <p:nvPr/>
         </p:nvSpPr>
         <p:spPr>
           <a:xfrm>
-            <a:off x="8394192" y="2852928"/>
-            <a:ext cx="3118104" cy="457200"/>
+            <a:off x="8394192" y="2779776"/>
+            <a:ext cx="3118104" cy="630936"/>
+          </a:xfrm>
+          <a:prstGeom prst="rect">
+            <a:avLst/>
+          </a:prstGeom>
+          <a:noFill/>
+          <a:effectLst/>
+        </p:spPr>
+        <p:txBody>
+          <a:bodyPr wrap="none" lIns="0" rIns="0" tIns="0" bIns="0">
+            <a:spAutoFit/>
+          </a:bodyPr>
+          <a:lstStyle/>
+          <a:p>
+            <a:pPr>
+              <a:spcAft>
+                <a:spcPts val="300"/>
+              </a:spcAft>
+              <a:defRPr sz="800" b="0">
+                <a:solidFill>
+                  <a:srgbClr val="62748A"/>
+                </a:solidFill>
+                <a:latin typeface="Noto Sans CJK SC"/>
+              </a:defRPr>
+            </a:pPr>
+            <a:r>
+              <a:t>VAE：变分自编码器，编码压缩、解码重建。</a:t>
+            </a:r>
+          </a:p>
+          <a:p>
+            <a:pPr>
+              <a:spcAft>
+                <a:spcPts val="300"/>
+              </a:spcAft>
+              <a:defRPr sz="800" b="0">
+                <a:solidFill>
+                  <a:srgbClr val="62748A"/>
+                </a:solidFill>
+                <a:latin typeface="Noto Sans CJK SC"/>
+              </a:defRPr>
+            </a:pPr>
+            <a:r>
+              <a:t>来自 Wan（Wang 等，2025），冻结使用。</a:t>
+            </a:r>
+          </a:p>
+          <a:p>
+            <a:pPr>
+              <a:spcAft>
+                <a:spcPts val="300"/>
+              </a:spcAft>
+              <a:defRPr sz="800" b="0">
+                <a:solidFill>
+                  <a:srgbClr val="62748A"/>
+                </a:solidFill>
+                <a:latin typeface="Noto Sans CJK SC"/>
+              </a:defRPr>
+            </a:pPr>
+            <a:r>
+              <a:t>向量维度 D：每个 token 包含 D 个数字。</a:t>
+            </a:r>
+          </a:p>
+        </p:txBody>
+      </p:sp>
+      <p:sp>
+        <p:nvSpPr>
+          <p:cNvPr id="50" name="Rounded Rectangle 49"/>
+          <p:cNvSpPr/>
+          <p:nvPr/>
+        </p:nvSpPr>
+        <p:spPr>
+          <a:xfrm>
+            <a:off x="8394192" y="3538728"/>
+            <a:ext cx="3118104" cy="621792"/>
+          </a:xfrm>
+          <a:prstGeom prst="roundRect">
+            <a:avLst>
+              <a:gd name="adj" fmla="val 12000"/>
+            </a:avLst>
+          </a:prstGeom>
+          <a:solidFill>
+            <a:srgbClr val="E8F4F2"/>
+          </a:solidFill>
+          <a:ln>
+            <a:noFill/>
+          </a:ln>
+          <a:effectLst/>
+        </p:spPr>
+        <p:style>
+          <a:lnRef idx="1">
+            <a:schemeClr val="accent1"/>
+          </a:lnRef>
+          <a:fillRef idx="3">
+            <a:schemeClr val="accent1"/>
+          </a:fillRef>
+          <a:effectRef idx="0">
+            <a:schemeClr val="accent1"/>
+          </a:effectRef>
+          <a:fontRef idx="minor">
+            <a:schemeClr val="lt1"/>
+          </a:fontRef>
+        </p:style>
+        <p:txBody>
+          <a:bodyPr rtlCol="0" anchor="ctr"/>
+          <a:lstStyle/>
+          <a:p>
+            <a:pPr algn="ctr"/>
+          </a:p>
+        </p:txBody>
+      </p:sp>
+      <p:sp>
+        <p:nvSpPr>
+          <p:cNvPr id="51" name="TextBox 50"/>
+          <p:cNvSpPr txBox="1"/>
+          <p:nvPr/>
+        </p:nvSpPr>
+        <p:spPr>
+          <a:xfrm>
+            <a:off x="8513064" y="3630168"/>
+            <a:ext cx="2880360" cy="246888"/>
+          </a:xfrm>
+          <a:prstGeom prst="rect">
+            <a:avLst/>
+          </a:prstGeom>
+          <a:noFill/>
+          <a:effectLst/>
+        </p:spPr>
+        <p:txBody>
+          <a:bodyPr wrap="none" lIns="0" rIns="0" tIns="0" bIns="0">
+            <a:spAutoFit/>
+          </a:bodyPr>
+          <a:lstStyle/>
+          <a:p>
+            <a:pPr>
+              <a:spcAft>
+                <a:spcPts val="700"/>
+              </a:spcAft>
+              <a:defRPr sz="1000" b="1">
+                <a:solidFill>
+                  <a:srgbClr val="148D91"/>
+                </a:solidFill>
+                <a:latin typeface="Noto Sans CJK SC"/>
+              </a:defRPr>
+            </a:pPr>
+            <a:r>
+              <a:t>视频输出头 → 视觉特征更新量</a:t>
+            </a:r>
+          </a:p>
+        </p:txBody>
+      </p:sp>
+      <p:sp>
+        <p:nvSpPr>
+          <p:cNvPr id="52" name="TextBox 51"/>
+          <p:cNvSpPr txBox="1"/>
+          <p:nvPr/>
+        </p:nvSpPr>
+        <p:spPr>
+          <a:xfrm>
+            <a:off x="8513064" y="3950208"/>
+            <a:ext cx="2880360" cy="182880"/>
+          </a:xfrm>
+          <a:prstGeom prst="rect">
+            <a:avLst/>
+          </a:prstGeom>
+          <a:noFill/>
+          <a:effectLst/>
+        </p:spPr>
+        <p:txBody>
+          <a:bodyPr wrap="none" lIns="0" rIns="0" tIns="0" bIns="0">
+            <a:spAutoFit/>
+          </a:bodyPr>
+          <a:lstStyle/>
+          <a:p>
+            <a:pPr>
+              <a:spcAft>
+                <a:spcPts val="700"/>
+              </a:spcAft>
+              <a:defRPr sz="800" b="0">
+                <a:solidFill>
+                  <a:srgbClr val="62748A"/>
+                </a:solidFill>
+                <a:latin typeface="Noto Sans CJK SC"/>
+              </a:defRPr>
+            </a:pPr>
+            <a:r>
+              <a:t>迭代恢复特征，再由 VAE 解码为 6 帧 RGB</a:t>
+            </a:r>
+          </a:p>
+        </p:txBody>
+      </p:sp>
+      <p:cxnSp>
+        <p:nvCxnSpPr>
+          <p:cNvPr id="53" name="Connector 52"/>
+          <p:cNvCxnSpPr/>
+          <p:nvPr/>
+        </p:nvCxnSpPr>
+        <p:spPr>
+          <a:xfrm>
+            <a:off x="8092440" y="3849624"/>
+            <a:ext cx="301752" cy="0"/>
+          </a:xfrm>
+          <a:prstGeom prst="line">
+            <a:avLst/>
+          </a:prstGeom>
+          <a:ln w="13970">
+            <a:solidFill>
+              <a:srgbClr val="148D91"/>
+            </a:solidFill>
+            <a:tailEnd type="triangle" w="med" len="med"/>
+          </a:ln>
+          <a:effectLst/>
+        </p:spPr>
+        <p:style>
+          <a:lnRef idx="2">
+            <a:schemeClr val="accent1"/>
+          </a:lnRef>
+          <a:fillRef idx="0">
+            <a:schemeClr val="accent1"/>
+          </a:fillRef>
+          <a:effectRef idx="0">
+            <a:schemeClr val="accent1"/>
+          </a:effectRef>
+          <a:fontRef idx="minor">
+            <a:schemeClr val="tx1"/>
+          </a:fontRef>
+        </p:style>
+      </p:cxnSp>
+      <p:sp>
+        <p:nvSpPr>
+          <p:cNvPr id="54" name="Rounded Rectangle 53"/>
+          <p:cNvSpPr/>
+          <p:nvPr/>
+        </p:nvSpPr>
+        <p:spPr>
+          <a:xfrm>
+            <a:off x="8394192" y="4315968"/>
+            <a:ext cx="3118104" cy="621792"/>
+          </a:xfrm>
+          <a:prstGeom prst="roundRect">
+            <a:avLst>
+              <a:gd name="adj" fmla="val 12000"/>
+            </a:avLst>
+          </a:prstGeom>
+          <a:solidFill>
+            <a:srgbClr val="E8F4F2"/>
+          </a:solidFill>
+          <a:ln>
+            <a:noFill/>
+          </a:ln>
+          <a:effectLst/>
+        </p:spPr>
+        <p:style>
+          <a:lnRef idx="1">
+            <a:schemeClr val="accent1"/>
+          </a:lnRef>
+          <a:fillRef idx="3">
+            <a:schemeClr val="accent1"/>
+          </a:fillRef>
+          <a:effectRef idx="0">
+            <a:schemeClr val="accent1"/>
+          </a:effectRef>
+          <a:fontRef idx="minor">
+            <a:schemeClr val="lt1"/>
+          </a:fontRef>
+        </p:style>
+        <p:txBody>
+          <a:bodyPr rtlCol="0" anchor="ctr"/>
+          <a:lstStyle/>
+          <a:p>
+            <a:pPr algn="ctr"/>
+          </a:p>
+        </p:txBody>
+      </p:sp>
+      <p:sp>
+        <p:nvSpPr>
+          <p:cNvPr id="55" name="TextBox 54"/>
+          <p:cNvSpPr txBox="1"/>
+          <p:nvPr/>
+        </p:nvSpPr>
+        <p:spPr>
+          <a:xfrm>
+            <a:off x="8513064" y="4407407"/>
+            <a:ext cx="2880360" cy="246888"/>
+          </a:xfrm>
+          <a:prstGeom prst="rect">
+            <a:avLst/>
+          </a:prstGeom>
+          <a:noFill/>
+          <a:effectLst/>
+        </p:spPr>
+        <p:txBody>
+          <a:bodyPr wrap="none" lIns="0" rIns="0" tIns="0" bIns="0">
+            <a:spAutoFit/>
+          </a:bodyPr>
+          <a:lstStyle/>
+          <a:p>
+            <a:pPr>
+              <a:spcAft>
+                <a:spcPts val="700"/>
+              </a:spcAft>
+              <a:defRPr sz="1000" b="1">
+                <a:solidFill>
+                  <a:srgbClr val="148D91"/>
+                </a:solidFill>
+                <a:latin typeface="Noto Sans CJK SC"/>
+              </a:defRPr>
+            </a:pPr>
+            <a:r>
+              <a:t>轨迹输出头 → 6 × 3 更新量</a:t>
+            </a:r>
+          </a:p>
+        </p:txBody>
+      </p:sp>
+      <p:sp>
+        <p:nvSpPr>
+          <p:cNvPr id="56" name="TextBox 55"/>
+          <p:cNvSpPr txBox="1"/>
+          <p:nvPr/>
+        </p:nvSpPr>
+        <p:spPr>
+          <a:xfrm>
+            <a:off x="8513064" y="4727448"/>
+            <a:ext cx="2880360" cy="182880"/>
+          </a:xfrm>
+          <a:prstGeom prst="rect">
+            <a:avLst/>
+          </a:prstGeom>
+          <a:noFill/>
+          <a:effectLst/>
+        </p:spPr>
+        <p:txBody>
+          <a:bodyPr wrap="none" lIns="0" rIns="0" tIns="0" bIns="0">
+            <a:spAutoFit/>
+          </a:bodyPr>
+          <a:lstStyle/>
+          <a:p>
+            <a:pPr>
+              <a:spcAft>
+                <a:spcPts val="700"/>
+              </a:spcAft>
+              <a:defRPr sz="800" b="0">
+                <a:solidFill>
+                  <a:srgbClr val="62748A"/>
+                </a:solidFill>
+                <a:latin typeface="Noto Sans CJK SC"/>
+              </a:defRPr>
+            </a:pPr>
+            <a:r>
+              <a:t>迭代后得到 6 × 3 的连续航点轨迹</a:t>
+            </a:r>
+          </a:p>
+        </p:txBody>
+      </p:sp>
+      <p:cxnSp>
+        <p:nvCxnSpPr>
+          <p:cNvPr id="57" name="Connector 56"/>
+          <p:cNvCxnSpPr/>
+          <p:nvPr/>
+        </p:nvCxnSpPr>
+        <p:spPr>
+          <a:xfrm>
+            <a:off x="8092440" y="4626864"/>
+            <a:ext cx="301752" cy="0"/>
+          </a:xfrm>
+          <a:prstGeom prst="line">
+            <a:avLst/>
+          </a:prstGeom>
+          <a:ln w="13970">
+            <a:solidFill>
+              <a:srgbClr val="148D91"/>
+            </a:solidFill>
+            <a:tailEnd type="triangle" w="med" len="med"/>
+          </a:ln>
+          <a:effectLst/>
+        </p:spPr>
+        <p:style>
+          <a:lnRef idx="2">
+            <a:schemeClr val="accent1"/>
+          </a:lnRef>
+          <a:fillRef idx="0">
+            <a:schemeClr val="accent1"/>
+          </a:fillRef>
+          <a:effectRef idx="0">
+            <a:schemeClr val="accent1"/>
+          </a:effectRef>
+          <a:fontRef idx="minor">
+            <a:schemeClr val="tx1"/>
+          </a:fontRef>
+        </p:style>
+      </p:cxnSp>
+      <p:sp>
+        <p:nvSpPr>
+          <p:cNvPr id="58" name="Rounded Rectangle 57"/>
+          <p:cNvSpPr/>
+          <p:nvPr/>
+        </p:nvSpPr>
+        <p:spPr>
+          <a:xfrm>
+            <a:off x="8394192" y="5093208"/>
+            <a:ext cx="3118104" cy="621792"/>
+          </a:xfrm>
+          <a:prstGeom prst="roundRect">
+            <a:avLst>
+              <a:gd name="adj" fmla="val 12000"/>
+            </a:avLst>
+          </a:prstGeom>
+          <a:solidFill>
+            <a:srgbClr val="E8F4F2"/>
+          </a:solidFill>
+          <a:ln>
+            <a:noFill/>
+          </a:ln>
+          <a:effectLst/>
+        </p:spPr>
+        <p:style>
+          <a:lnRef idx="1">
+            <a:schemeClr val="accent1"/>
+          </a:lnRef>
+          <a:fillRef idx="3">
+            <a:schemeClr val="accent1"/>
+          </a:fillRef>
+          <a:effectRef idx="0">
+            <a:schemeClr val="accent1"/>
+          </a:effectRef>
+          <a:fontRef idx="minor">
+            <a:schemeClr val="lt1"/>
+          </a:fontRef>
+        </p:style>
+        <p:txBody>
+          <a:bodyPr rtlCol="0" anchor="ctr"/>
+          <a:lstStyle/>
+          <a:p>
+            <a:pPr algn="ctr"/>
+          </a:p>
+        </p:txBody>
+      </p:sp>
+      <p:sp>
+        <p:nvSpPr>
+          <p:cNvPr id="59" name="TextBox 58"/>
+          <p:cNvSpPr txBox="1"/>
+          <p:nvPr/>
+        </p:nvSpPr>
+        <p:spPr>
+          <a:xfrm>
+            <a:off x="8513064" y="5184648"/>
+            <a:ext cx="2880360" cy="246888"/>
+          </a:xfrm>
+          <a:prstGeom prst="rect">
+            <a:avLst/>
+          </a:prstGeom>
+          <a:noFill/>
+          <a:effectLst/>
+        </p:spPr>
+        <p:txBody>
+          <a:bodyPr wrap="none" lIns="0" rIns="0" tIns="0" bIns="0">
+            <a:spAutoFit/>
+          </a:bodyPr>
+          <a:lstStyle/>
+          <a:p>
+            <a:pPr>
+              <a:spcAft>
+                <a:spcPts val="700"/>
+              </a:spcAft>
+              <a:defRPr sz="1000" b="1">
+                <a:solidFill>
+                  <a:srgbClr val="148D91"/>
+                </a:solidFill>
+                <a:latin typeface="Noto Sans CJK SC"/>
+              </a:defRPr>
+            </a:pPr>
+            <a:r>
+              <a:t>几何输出头 → 几何特征更新量</a:t>
+            </a:r>
+          </a:p>
+        </p:txBody>
+      </p:sp>
+      <p:sp>
+        <p:nvSpPr>
+          <p:cNvPr id="60" name="TextBox 59"/>
+          <p:cNvSpPr txBox="1"/>
+          <p:nvPr/>
+        </p:nvSpPr>
+        <p:spPr>
+          <a:xfrm>
+            <a:off x="8513064" y="5504688"/>
+            <a:ext cx="2880360" cy="182880"/>
+          </a:xfrm>
+          <a:prstGeom prst="rect">
+            <a:avLst/>
+          </a:prstGeom>
+          <a:noFill/>
+          <a:effectLst/>
+        </p:spPr>
+        <p:txBody>
+          <a:bodyPr wrap="none" lIns="0" rIns="0" tIns="0" bIns="0">
+            <a:spAutoFit/>
+          </a:bodyPr>
+          <a:lstStyle/>
+          <a:p>
+            <a:pPr>
+              <a:spcAft>
+                <a:spcPts val="700"/>
+              </a:spcAft>
+              <a:defRPr sz="800" b="0">
+                <a:solidFill>
+                  <a:srgbClr val="62748A"/>
+                </a:solidFill>
+                <a:latin typeface="Noto Sans CJK SC"/>
+              </a:defRPr>
+            </a:pPr>
+            <a:r>
+              <a:t>迭代后恢复未来视角的相机几何特征</a:t>
+            </a:r>
+          </a:p>
+        </p:txBody>
+      </p:sp>
+      <p:cxnSp>
+        <p:nvCxnSpPr>
+          <p:cNvPr id="61" name="Connector 60"/>
+          <p:cNvCxnSpPr/>
+          <p:nvPr/>
+        </p:nvCxnSpPr>
+        <p:spPr>
+          <a:xfrm>
+            <a:off x="8092440" y="5404104"/>
+            <a:ext cx="301752" cy="0"/>
+          </a:xfrm>
+          <a:prstGeom prst="line">
+            <a:avLst/>
+          </a:prstGeom>
+          <a:ln w="13970">
+            <a:solidFill>
+              <a:srgbClr val="148D91"/>
+            </a:solidFill>
+            <a:tailEnd type="triangle" w="med" len="med"/>
+          </a:ln>
+          <a:effectLst/>
+        </p:spPr>
+        <p:style>
+          <a:lnRef idx="2">
+            <a:schemeClr val="accent1"/>
+          </a:lnRef>
+          <a:fillRef idx="0">
+            <a:schemeClr val="accent1"/>
+          </a:fillRef>
+          <a:effectRef idx="0">
+            <a:schemeClr val="accent1"/>
+          </a:effectRef>
+          <a:fontRef idx="minor">
+            <a:schemeClr val="tx1"/>
+          </a:fontRef>
+        </p:style>
+      </p:cxnSp>
+      <p:sp>
+        <p:nvSpPr>
+          <p:cNvPr id="62" name="TextBox 61"/>
+          <p:cNvSpPr txBox="1"/>
+          <p:nvPr/>
+        </p:nvSpPr>
+        <p:spPr>
+          <a:xfrm>
+            <a:off x="685800" y="5888736"/>
+            <a:ext cx="10826496" cy="246888"/>
           </a:xfrm>
           <a:prstGeom prst="rect">
             <a:avLst/>
@@ -5502,37 +6124,21 @@
               </a:defRPr>
             </a:pPr>
             <a:r>
-              <a:t>历史与目标只作条件；</a:t>
-            </a:r>
-          </a:p>
-          <a:p>
-            <a:pPr>
-              <a:spcAft>
-                <a:spcPts val="700"/>
-              </a:spcAft>
-              <a:defRPr sz="1000" b="0">
-                <a:solidFill>
-                  <a:srgbClr val="62748A"/>
-                </a:solidFill>
-                <a:latin typeface="Noto Sans CJK SC"/>
-              </a:defRPr>
-            </a:pPr>
-            <a:r>
-              <a:t>下方三支输出的是更新量。</a:t>
-            </a:r>
-          </a:p>
-        </p:txBody>
-      </p:sp>
-      <p:sp>
-        <p:nvSpPr>
-          <p:cNvPr id="49" name="Rounded Rectangle 48"/>
+              <a:t>另加入可学习的寄存向量帮助信息交流；视觉向量保留时空位置编码，其余类型不强加图像网格位置。</a:t>
+            </a:r>
+          </a:p>
+        </p:txBody>
+      </p:sp>
+      <p:sp>
+        <p:nvSpPr>
+          <p:cNvPr id="63" name="Rounded Rectangle 62"/>
           <p:cNvSpPr/>
           <p:nvPr/>
         </p:nvSpPr>
         <p:spPr>
           <a:xfrm>
-            <a:off x="8394192" y="3538728"/>
-            <a:ext cx="3118104" cy="621792"/>
+            <a:off x="685800" y="6272784"/>
+            <a:ext cx="10826496" cy="365760"/>
           </a:xfrm>
           <a:prstGeom prst="roundRect">
             <a:avLst>
@@ -5571,14 +6177,14 @@
       </p:sp>
       <p:sp>
         <p:nvSpPr>
-          <p:cNvPr id="50" name="TextBox 49"/>
+          <p:cNvPr id="64" name="TextBox 63"/>
           <p:cNvSpPr txBox="1"/>
           <p:nvPr/>
         </p:nvSpPr>
         <p:spPr>
           <a:xfrm>
-            <a:off x="8513064" y="3630168"/>
-            <a:ext cx="2880360" cy="246888"/>
+            <a:off x="859536" y="6336792"/>
+            <a:ext cx="10424160" cy="256032"/>
           </a:xfrm>
           <a:prstGeom prst="rect">
             <a:avLst/>
@@ -5596,7 +6202,7 @@
               <a:spcAft>
                 <a:spcPts val="700"/>
               </a:spcAft>
-              <a:defRPr sz="1000" b="1">
+              <a:defRPr sz="1200" b="1">
                 <a:solidFill>
                   <a:srgbClr val="148D91"/>
                 </a:solidFill>
@@ -5604,21 +6210,21 @@
               </a:defRPr>
             </a:pPr>
             <a:r>
-              <a:t>视频输出头 → 视觉特征更新量</a:t>
-            </a:r>
-          </a:p>
-        </p:txBody>
-      </p:sp>
-      <p:sp>
-        <p:nvSpPr>
-          <p:cNvPr id="51" name="TextBox 50"/>
+              <a:t>参数更新：VAE 与 DA3 冻结；共享网络、新增 MLP 与输出头训练。更新量不是机器人速度。</a:t>
+            </a:r>
+          </a:p>
+        </p:txBody>
+      </p:sp>
+      <p:sp>
+        <p:nvSpPr>
+          <p:cNvPr id="65" name="TextBox 64"/>
           <p:cNvSpPr txBox="1"/>
           <p:nvPr/>
         </p:nvSpPr>
         <p:spPr>
           <a:xfrm>
-            <a:off x="8513064" y="3950208"/>
-            <a:ext cx="2880360" cy="182880"/>
+            <a:off x="685800" y="6711696"/>
+            <a:ext cx="10058400" cy="137160"/>
           </a:xfrm>
           <a:prstGeom prst="rect">
             <a:avLst/>
@@ -5644,543 +6250,14 @@
               </a:defRPr>
             </a:pPr>
             <a:r>
-              <a:t>迭代恢复特征，再由 VAE 解码为 6 帧 RGB</a:t>
-            </a:r>
-          </a:p>
-        </p:txBody>
-      </p:sp>
-      <p:cxnSp>
-        <p:nvCxnSpPr>
-          <p:cNvPr id="52" name="Connector 51"/>
-          <p:cNvCxnSpPr/>
-          <p:nvPr/>
-        </p:nvCxnSpPr>
-        <p:spPr>
-          <a:xfrm>
-            <a:off x="8092440" y="3849624"/>
-            <a:ext cx="301752" cy="0"/>
-          </a:xfrm>
-          <a:prstGeom prst="line">
-            <a:avLst/>
-          </a:prstGeom>
-          <a:ln w="13970">
-            <a:solidFill>
-              <a:srgbClr val="148D91"/>
-            </a:solidFill>
-            <a:tailEnd type="triangle" w="med" len="med"/>
-          </a:ln>
-          <a:effectLst/>
-        </p:spPr>
-        <p:style>
-          <a:lnRef idx="2">
-            <a:schemeClr val="accent1"/>
-          </a:lnRef>
-          <a:fillRef idx="0">
-            <a:schemeClr val="accent1"/>
-          </a:fillRef>
-          <a:effectRef idx="0">
-            <a:schemeClr val="accent1"/>
-          </a:effectRef>
-          <a:fontRef idx="minor">
-            <a:schemeClr val="tx1"/>
-          </a:fontRef>
-        </p:style>
-      </p:cxnSp>
-      <p:sp>
-        <p:nvSpPr>
-          <p:cNvPr id="53" name="Rounded Rectangle 52"/>
-          <p:cNvSpPr/>
-          <p:nvPr/>
-        </p:nvSpPr>
-        <p:spPr>
-          <a:xfrm>
-            <a:off x="8394192" y="4315968"/>
-            <a:ext cx="3118104" cy="621792"/>
-          </a:xfrm>
-          <a:prstGeom prst="roundRect">
-            <a:avLst>
-              <a:gd name="adj" fmla="val 12000"/>
-            </a:avLst>
-          </a:prstGeom>
-          <a:solidFill>
-            <a:srgbClr val="E8F4F2"/>
-          </a:solidFill>
-          <a:ln>
-            <a:noFill/>
-          </a:ln>
-          <a:effectLst/>
-        </p:spPr>
-        <p:style>
-          <a:lnRef idx="1">
-            <a:schemeClr val="accent1"/>
-          </a:lnRef>
-          <a:fillRef idx="3">
-            <a:schemeClr val="accent1"/>
-          </a:fillRef>
-          <a:effectRef idx="0">
-            <a:schemeClr val="accent1"/>
-          </a:effectRef>
-          <a:fontRef idx="minor">
-            <a:schemeClr val="lt1"/>
-          </a:fontRef>
-        </p:style>
-        <p:txBody>
-          <a:bodyPr rtlCol="0" anchor="ctr"/>
-          <a:lstStyle/>
-          <a:p>
-            <a:pPr algn="ctr"/>
-          </a:p>
-        </p:txBody>
-      </p:sp>
-      <p:sp>
-        <p:nvSpPr>
-          <p:cNvPr id="54" name="TextBox 53"/>
-          <p:cNvSpPr txBox="1"/>
-          <p:nvPr/>
-        </p:nvSpPr>
-        <p:spPr>
-          <a:xfrm>
-            <a:off x="8513064" y="4407407"/>
-            <a:ext cx="2880360" cy="246888"/>
-          </a:xfrm>
-          <a:prstGeom prst="rect">
-            <a:avLst/>
-          </a:prstGeom>
-          <a:noFill/>
-          <a:effectLst/>
-        </p:spPr>
-        <p:txBody>
-          <a:bodyPr wrap="none" lIns="0" rIns="0" tIns="0" bIns="0">
-            <a:spAutoFit/>
-          </a:bodyPr>
-          <a:lstStyle/>
-          <a:p>
-            <a:pPr>
-              <a:spcAft>
-                <a:spcPts val="700"/>
-              </a:spcAft>
-              <a:defRPr sz="1000" b="1">
-                <a:solidFill>
-                  <a:srgbClr val="148D91"/>
-                </a:solidFill>
-                <a:latin typeface="Noto Sans CJK SC"/>
-              </a:defRPr>
-            </a:pPr>
-            <a:r>
-              <a:t>轨迹输出头 → 6 × 3 更新量</a:t>
-            </a:r>
-          </a:p>
-        </p:txBody>
-      </p:sp>
-      <p:sp>
-        <p:nvSpPr>
-          <p:cNvPr id="55" name="TextBox 54"/>
-          <p:cNvSpPr txBox="1"/>
-          <p:nvPr/>
-        </p:nvSpPr>
-        <p:spPr>
-          <a:xfrm>
-            <a:off x="8513064" y="4727448"/>
-            <a:ext cx="2880360" cy="182880"/>
-          </a:xfrm>
-          <a:prstGeom prst="rect">
-            <a:avLst/>
-          </a:prstGeom>
-          <a:noFill/>
-          <a:effectLst/>
-        </p:spPr>
-        <p:txBody>
-          <a:bodyPr wrap="none" lIns="0" rIns="0" tIns="0" bIns="0">
-            <a:spAutoFit/>
-          </a:bodyPr>
-          <a:lstStyle/>
-          <a:p>
-            <a:pPr>
-              <a:spcAft>
-                <a:spcPts val="700"/>
-              </a:spcAft>
-              <a:defRPr sz="800" b="0">
-                <a:solidFill>
-                  <a:srgbClr val="62748A"/>
-                </a:solidFill>
-                <a:latin typeface="Noto Sans CJK SC"/>
-              </a:defRPr>
-            </a:pPr>
-            <a:r>
-              <a:t>迭代后得到 6 × 3 的连续航点轨迹</a:t>
-            </a:r>
-          </a:p>
-        </p:txBody>
-      </p:sp>
-      <p:cxnSp>
-        <p:nvCxnSpPr>
-          <p:cNvPr id="56" name="Connector 55"/>
-          <p:cNvCxnSpPr/>
-          <p:nvPr/>
-        </p:nvCxnSpPr>
-        <p:spPr>
-          <a:xfrm>
-            <a:off x="8092440" y="4626864"/>
-            <a:ext cx="301752" cy="0"/>
-          </a:xfrm>
-          <a:prstGeom prst="line">
-            <a:avLst/>
-          </a:prstGeom>
-          <a:ln w="13970">
-            <a:solidFill>
-              <a:srgbClr val="148D91"/>
-            </a:solidFill>
-            <a:tailEnd type="triangle" w="med" len="med"/>
-          </a:ln>
-          <a:effectLst/>
-        </p:spPr>
-        <p:style>
-          <a:lnRef idx="2">
-            <a:schemeClr val="accent1"/>
-          </a:lnRef>
-          <a:fillRef idx="0">
-            <a:schemeClr val="accent1"/>
-          </a:fillRef>
-          <a:effectRef idx="0">
-            <a:schemeClr val="accent1"/>
-          </a:effectRef>
-          <a:fontRef idx="minor">
-            <a:schemeClr val="tx1"/>
-          </a:fontRef>
-        </p:style>
-      </p:cxnSp>
-      <p:sp>
-        <p:nvSpPr>
-          <p:cNvPr id="57" name="Rounded Rectangle 56"/>
-          <p:cNvSpPr/>
-          <p:nvPr/>
-        </p:nvSpPr>
-        <p:spPr>
-          <a:xfrm>
-            <a:off x="8394192" y="5093208"/>
-            <a:ext cx="3118104" cy="621792"/>
-          </a:xfrm>
-          <a:prstGeom prst="roundRect">
-            <a:avLst>
-              <a:gd name="adj" fmla="val 12000"/>
-            </a:avLst>
-          </a:prstGeom>
-          <a:solidFill>
-            <a:srgbClr val="E8F4F2"/>
-          </a:solidFill>
-          <a:ln>
-            <a:noFill/>
-          </a:ln>
-          <a:effectLst/>
-        </p:spPr>
-        <p:style>
-          <a:lnRef idx="1">
-            <a:schemeClr val="accent1"/>
-          </a:lnRef>
-          <a:fillRef idx="3">
-            <a:schemeClr val="accent1"/>
-          </a:fillRef>
-          <a:effectRef idx="0">
-            <a:schemeClr val="accent1"/>
-          </a:effectRef>
-          <a:fontRef idx="minor">
-            <a:schemeClr val="lt1"/>
-          </a:fontRef>
-        </p:style>
-        <p:txBody>
-          <a:bodyPr rtlCol="0" anchor="ctr"/>
-          <a:lstStyle/>
-          <a:p>
-            <a:pPr algn="ctr"/>
-          </a:p>
-        </p:txBody>
-      </p:sp>
-      <p:sp>
-        <p:nvSpPr>
-          <p:cNvPr id="58" name="TextBox 57"/>
-          <p:cNvSpPr txBox="1"/>
-          <p:nvPr/>
-        </p:nvSpPr>
-        <p:spPr>
-          <a:xfrm>
-            <a:off x="8513064" y="5184648"/>
-            <a:ext cx="2880360" cy="246888"/>
-          </a:xfrm>
-          <a:prstGeom prst="rect">
-            <a:avLst/>
-          </a:prstGeom>
-          <a:noFill/>
-          <a:effectLst/>
-        </p:spPr>
-        <p:txBody>
-          <a:bodyPr wrap="none" lIns="0" rIns="0" tIns="0" bIns="0">
-            <a:spAutoFit/>
-          </a:bodyPr>
-          <a:lstStyle/>
-          <a:p>
-            <a:pPr>
-              <a:spcAft>
-                <a:spcPts val="700"/>
-              </a:spcAft>
-              <a:defRPr sz="1000" b="1">
-                <a:solidFill>
-                  <a:srgbClr val="148D91"/>
-                </a:solidFill>
-                <a:latin typeface="Noto Sans CJK SC"/>
-              </a:defRPr>
-            </a:pPr>
-            <a:r>
-              <a:t>几何输出头 → 几何特征更新量</a:t>
-            </a:r>
-          </a:p>
-        </p:txBody>
-      </p:sp>
-      <p:sp>
-        <p:nvSpPr>
-          <p:cNvPr id="59" name="TextBox 58"/>
-          <p:cNvSpPr txBox="1"/>
-          <p:nvPr/>
-        </p:nvSpPr>
-        <p:spPr>
-          <a:xfrm>
-            <a:off x="8513064" y="5504688"/>
-            <a:ext cx="2880360" cy="182880"/>
-          </a:xfrm>
-          <a:prstGeom prst="rect">
-            <a:avLst/>
-          </a:prstGeom>
-          <a:noFill/>
-          <a:effectLst/>
-        </p:spPr>
-        <p:txBody>
-          <a:bodyPr wrap="none" lIns="0" rIns="0" tIns="0" bIns="0">
-            <a:spAutoFit/>
-          </a:bodyPr>
-          <a:lstStyle/>
-          <a:p>
-            <a:pPr>
-              <a:spcAft>
-                <a:spcPts val="700"/>
-              </a:spcAft>
-              <a:defRPr sz="800" b="0">
-                <a:solidFill>
-                  <a:srgbClr val="62748A"/>
-                </a:solidFill>
-                <a:latin typeface="Noto Sans CJK SC"/>
-              </a:defRPr>
-            </a:pPr>
-            <a:r>
-              <a:t>迭代后恢复未来视角的相机几何特征</a:t>
-            </a:r>
-          </a:p>
-        </p:txBody>
-      </p:sp>
-      <p:cxnSp>
-        <p:nvCxnSpPr>
-          <p:cNvPr id="60" name="Connector 59"/>
-          <p:cNvCxnSpPr/>
-          <p:nvPr/>
-        </p:nvCxnSpPr>
-        <p:spPr>
-          <a:xfrm>
-            <a:off x="8092440" y="5404104"/>
-            <a:ext cx="301752" cy="0"/>
-          </a:xfrm>
-          <a:prstGeom prst="line">
-            <a:avLst/>
-          </a:prstGeom>
-          <a:ln w="13970">
-            <a:solidFill>
-              <a:srgbClr val="148D91"/>
-            </a:solidFill>
-            <a:tailEnd type="triangle" w="med" len="med"/>
-          </a:ln>
-          <a:effectLst/>
-        </p:spPr>
-        <p:style>
-          <a:lnRef idx="2">
-            <a:schemeClr val="accent1"/>
-          </a:lnRef>
-          <a:fillRef idx="0">
-            <a:schemeClr val="accent1"/>
-          </a:fillRef>
-          <a:effectRef idx="0">
-            <a:schemeClr val="accent1"/>
-          </a:effectRef>
-          <a:fontRef idx="minor">
-            <a:schemeClr val="tx1"/>
-          </a:fontRef>
-        </p:style>
-      </p:cxnSp>
-      <p:sp>
-        <p:nvSpPr>
-          <p:cNvPr id="61" name="TextBox 60"/>
-          <p:cNvSpPr txBox="1"/>
-          <p:nvPr/>
-        </p:nvSpPr>
-        <p:spPr>
-          <a:xfrm>
-            <a:off x="685800" y="5888736"/>
-            <a:ext cx="10826496" cy="246888"/>
-          </a:xfrm>
-          <a:prstGeom prst="rect">
-            <a:avLst/>
-          </a:prstGeom>
-          <a:noFill/>
-          <a:effectLst/>
-        </p:spPr>
-        <p:txBody>
-          <a:bodyPr wrap="none" lIns="0" rIns="0" tIns="0" bIns="0">
-            <a:spAutoFit/>
-          </a:bodyPr>
-          <a:lstStyle/>
-          <a:p>
-            <a:pPr>
-              <a:spcAft>
-                <a:spcPts val="700"/>
-              </a:spcAft>
-              <a:defRPr sz="1000" b="0">
-                <a:solidFill>
-                  <a:srgbClr val="62748A"/>
-                </a:solidFill>
-                <a:latin typeface="Noto Sans CJK SC"/>
-              </a:defRPr>
-            </a:pPr>
-            <a:r>
-              <a:t>另加入可学习的寄存向量帮助信息交流；视觉向量保留时空位置编码，其余类型不强加图像网格位置。</a:t>
-            </a:r>
-          </a:p>
-        </p:txBody>
-      </p:sp>
-      <p:sp>
-        <p:nvSpPr>
-          <p:cNvPr id="62" name="Rounded Rectangle 61"/>
-          <p:cNvSpPr/>
-          <p:nvPr/>
-        </p:nvSpPr>
-        <p:spPr>
-          <a:xfrm>
-            <a:off x="685800" y="6272784"/>
-            <a:ext cx="10826496" cy="365760"/>
-          </a:xfrm>
-          <a:prstGeom prst="roundRect">
-            <a:avLst>
-              <a:gd name="adj" fmla="val 12000"/>
-            </a:avLst>
-          </a:prstGeom>
-          <a:solidFill>
-            <a:srgbClr val="E8F4F2"/>
-          </a:solidFill>
-          <a:ln>
-            <a:noFill/>
-          </a:ln>
-          <a:effectLst/>
-        </p:spPr>
-        <p:style>
-          <a:lnRef idx="1">
-            <a:schemeClr val="accent1"/>
-          </a:lnRef>
-          <a:fillRef idx="3">
-            <a:schemeClr val="accent1"/>
-          </a:fillRef>
-          <a:effectRef idx="0">
-            <a:schemeClr val="accent1"/>
-          </a:effectRef>
-          <a:fontRef idx="minor">
-            <a:schemeClr val="lt1"/>
-          </a:fontRef>
-        </p:style>
-        <p:txBody>
-          <a:bodyPr rtlCol="0" anchor="ctr"/>
-          <a:lstStyle/>
-          <a:p>
-            <a:pPr algn="ctr"/>
-          </a:p>
-        </p:txBody>
-      </p:sp>
-      <p:sp>
-        <p:nvSpPr>
-          <p:cNvPr id="63" name="TextBox 62"/>
-          <p:cNvSpPr txBox="1"/>
-          <p:nvPr/>
-        </p:nvSpPr>
-        <p:spPr>
-          <a:xfrm>
-            <a:off x="859536" y="6336792"/>
-            <a:ext cx="10424160" cy="256032"/>
-          </a:xfrm>
-          <a:prstGeom prst="rect">
-            <a:avLst/>
-          </a:prstGeom>
-          <a:noFill/>
-          <a:effectLst/>
-        </p:spPr>
-        <p:txBody>
-          <a:bodyPr wrap="none" lIns="0" rIns="0" tIns="0" bIns="0">
-            <a:spAutoFit/>
-          </a:bodyPr>
-          <a:lstStyle/>
-          <a:p>
-            <a:pPr>
-              <a:spcAft>
-                <a:spcPts val="700"/>
-              </a:spcAft>
-              <a:defRPr sz="1200" b="1">
-                <a:solidFill>
-                  <a:srgbClr val="148D91"/>
-                </a:solidFill>
-                <a:latin typeface="Noto Sans CJK SC"/>
-              </a:defRPr>
-            </a:pPr>
-            <a:r>
-              <a:t>参数更新：VAE 与 DA3 冻结；共享网络、新增 MLP 与输出头训练。更新量不是机器人速度。</a:t>
-            </a:r>
-          </a:p>
-        </p:txBody>
-      </p:sp>
-      <p:sp>
-        <p:nvSpPr>
-          <p:cNvPr id="64" name="TextBox 63"/>
-          <p:cNvSpPr txBox="1"/>
-          <p:nvPr/>
-        </p:nvSpPr>
-        <p:spPr>
-          <a:xfrm>
-            <a:off x="685800" y="6711696"/>
-            <a:ext cx="10058400" cy="137160"/>
-          </a:xfrm>
-          <a:prstGeom prst="rect">
-            <a:avLst/>
-          </a:prstGeom>
-          <a:noFill/>
-          <a:effectLst/>
-        </p:spPr>
-        <p:txBody>
-          <a:bodyPr wrap="none" lIns="0" rIns="0" tIns="0" bIns="0">
-            <a:spAutoFit/>
-          </a:bodyPr>
-          <a:lstStyle/>
-          <a:p>
-            <a:pPr>
-              <a:spcAft>
-                <a:spcPts val="700"/>
-              </a:spcAft>
-              <a:defRPr sz="800" b="0">
-                <a:solidFill>
-                  <a:srgbClr val="62748A"/>
-                </a:solidFill>
-                <a:latin typeface="Noto Sans CJK SC"/>
-              </a:defRPr>
-            </a:pPr>
-            <a:r>
-              <a:t>来源：UniNav §3.2–3.3、图 2；正文未给出视觉向量数量、隐藏维度及几何特征维度，本页不补造。</a:t>
-            </a:r>
-          </a:p>
-        </p:txBody>
-      </p:sp>
-      <p:sp>
-        <p:nvSpPr>
-          <p:cNvPr id="65" name="TextBox 64"/>
+              <a:t>来源：UniNav §3.2–3.3；Wan（2025）；DA3（2025）。具体压缩尺寸、切块大小、D 与几何维度未披露。</a:t>
+            </a:r>
+          </a:p>
+        </p:txBody>
+      </p:sp>
+      <p:sp>
+        <p:nvSpPr>
+          <p:cNvPr id="66" name="TextBox 65"/>
           <p:cNvSpPr txBox="1"/>
           <p:nvPr/>
         </p:nvSpPr>

</xml_diff>